<commit_message>
done for teh matches and
</commit_message>
<xml_diff>
--- a/AsteroidsFX-Presentation.pptx
+++ b/AsteroidsFX-Presentation.pptx
@@ -5158,7 +5158,7 @@
                 <a:ea typeface="Calibri" pitchFamily="34" charset="-122"/>
                 <a:cs typeface="Calibri" pitchFamily="34" charset="-120"/>
               </a:rPr>
-              <a:t>Five test classes in total, run by mvn test across four modules</a:t>
+              <a:t>Five test classes and 21 tests in total, run by mvn test across four modules — all passing</a:t>
             </a:r>
             <a:endParaRPr lang="en-US" sz="1200" dirty="0"/>
           </a:p>
@@ -7314,7 +7314,7 @@
                 <a:ea typeface="Calibri" pitchFamily="34" charset="-122"/>
                 <a:cs typeface="Calibri" pitchFamily="34" charset="-120"/>
               </a:rPr>
-              <a:t>Clear three waves to win. Three lives, brief invulnerability on respawn.</a:t>
+              <a:t>Clear three waves to win. Three lives, brief invulnerability on respawn.   Keys 1 / 2 / 3 install and uninstall the Player, Enemy and Weapon components while the game runs.</a:t>
             </a:r>
             <a:endParaRPr lang="en-US" sz="1100" dirty="0"/>
           </a:p>
@@ -9140,7 +9140,7 @@
                 <a:ea typeface="Cambria" pitchFamily="34" charset="-122"/>
                 <a:cs typeface="Cambria" pitchFamily="34" charset="-120"/>
               </a:rPr>
-              <a:t>5</a:t>
+              <a:t>21</a:t>
             </a:r>
             <a:endParaRPr lang="en-US" sz="4600" dirty="0"/>
           </a:p>
@@ -9179,7 +9179,7 @@
                 <a:ea typeface="Calibri" pitchFamily="34" charset="-122"/>
                 <a:cs typeface="Calibri" pitchFamily="34" charset="-120"/>
               </a:rPr>
-              <a:t>test classes</a:t>
+              <a:t>tests, all passing</a:t>
             </a:r>
             <a:endParaRPr lang="en-US" sz="1250" dirty="0"/>
           </a:p>
@@ -13679,6 +13679,30 @@
             </a:r>
             <a:endParaRPr lang="en-US" sz="1200" dirty="0"/>
           </a:p>
+          <a:p>
+            <a:pPr marL="342900" indent="-342900">
+              <a:lnSpc>
+                <a:spcPts val="1584"/>
+              </a:lnSpc>
+              <a:spcAft>
+                <a:spcPts val="600"/>
+              </a:spcAft>
+              <a:buSzPct val="100000"/>
+              <a:buChar char="•"/>
+            </a:pPr>
+            <a:r>
+              <a:rPr lang="en-US" sz="1200" dirty="0">
+                <a:solidFill>
+                  <a:srgbClr val="18213D"/>
+                </a:solidFill>
+                <a:latin typeface="Calibri" pitchFamily="34" charset="0"/>
+                <a:ea typeface="Calibri" pitchFamily="34" charset="-122"/>
+                <a:cs typeface="Calibri" pitchFamily="34" charset="-120"/>
+              </a:rPr>
+              <a:t>Ships that collide with asteroids are destroyed</a:t>
+            </a:r>
+            <a:endParaRPr lang="en-US" sz="1200" dirty="0"/>
+          </a:p>
         </p:txBody>
       </p:sp>
       <p:sp>
@@ -13867,6 +13891,30 @@
                 <a:cs typeface="Calibri" pitchFamily="34" charset="-120"/>
               </a:rPr>
               <a:t>Entity carries maxHealth, so an enemy survives two bullets and dies on the third</a:t>
+            </a:r>
+            <a:endParaRPr lang="en-US" sz="1200" dirty="0"/>
+          </a:p>
+          <a:p>
+            <a:pPr marL="342900" indent="-342900">
+              <a:lnSpc>
+                <a:spcPts val="1584"/>
+              </a:lnSpc>
+              <a:spcAft>
+                <a:spcPts val="600"/>
+              </a:spcAft>
+              <a:buSzPct val="100000"/>
+              <a:buChar char="•"/>
+            </a:pPr>
+            <a:r>
+              <a:rPr lang="en-US" sz="1200" dirty="0">
+                <a:solidFill>
+                  <a:srgbClr val="18213D"/>
+                </a:solidFill>
+                <a:latin typeface="Calibri" pitchFamily="34" charset="0"/>
+                <a:ea typeface="Calibri" pitchFamily="34" charset="-122"/>
+                <a:cs typeface="Calibri" pitchFamily="34" charset="-120"/>
+              </a:rPr>
+              <a:t>A ship that flies into a rock is destroyed outright — the enemy saucer too, and the asteroid still splits; no score, since the player did not shoot it</a:t>
             </a:r>
             <a:endParaRPr lang="en-US" sz="1200" dirty="0"/>
           </a:p>
@@ -16126,6 +16174,26 @@
                 <a:cs typeface="Courier New" pitchFamily="34" charset="-120"/>
               </a:rPr>
               <a:t>    exports dk.sdu.mmmi.cbse.common.util;</a:t>
+            </a:r>
+            <a:endParaRPr lang="en-US" sz="945" dirty="0"/>
+          </a:p>
+          <a:p>
+            <a:pPr indent="0" marL="0">
+              <a:lnSpc>
+                <a:spcPts val="1343"/>
+              </a:lnSpc>
+              <a:buNone/>
+            </a:pPr>
+            <a:r>
+              <a:rPr lang="en-US" sz="945" dirty="0">
+                <a:solidFill>
+                  <a:srgbClr val="7FB3F5"/>
+                </a:solidFill>
+                <a:latin typeface="Courier New" pitchFamily="34" charset="0"/>
+                <a:ea typeface="Courier New" pitchFamily="34" charset="-122"/>
+                <a:cs typeface="Courier New" pitchFamily="34" charset="-120"/>
+              </a:rPr>
+              <a:t>    exports dk.sdu.mmmi.cbse.common.sound;</a:t>
             </a:r>
             <a:endParaRPr lang="en-US" sz="945" dirty="0"/>
           </a:p>

</xml_diff>